<commit_message>
Fix presentation model wording
</commit_message>
<xml_diff>
--- a/public/a-eye-presentation/A-Eye_midterm_data_collection_forecast.pptx
+++ b/public/a-eye-presentation/A-Eye_midterm_data_collection_forecast.pptx
@@ -1629,15 +1629,10 @@
               <a:buNone/>
             </a:pPr>
             <a:r>
-              <a:rPr lang="en-US" sz="1100" b="1" dirty="0">
-                <a:solidFill>
-                  <a:srgbClr val="1A1A1A"/>
-                </a:solidFill>
-                <a:latin typeface="Arial" pitchFamily="34" charset="0"/>
-                <a:ea typeface="Arial" pitchFamily="34" charset="-122"/>
-                <a:cs typeface="Arial" pitchFamily="34" charset="-120"/>
-              </a:rPr>
-              <a:t>Three.js  ·  OpenStreetMap  ·  Cloudflare Pages  ·  PyTorch</a:t>
+              <a:rPr sz="1300">
+                <a:latin typeface="Malgun Gothic"/>
+              </a:rPr>
+              <a:t>Three.js  ·  OpenStreetMap  ·  Cloudflare Pages  ·  Colab/scikit-learn</a:t>
             </a:r>
             <a:endParaRPr lang="en-US" sz="1100" dirty="0"/>
           </a:p>
@@ -3064,10 +3059,7 @@
           <a:p>
             <a:pPr algn="l"/>
             <a:r>
-              <a:rPr sz="2400" b="1">
-                <a:solidFill>
-                  <a:srgbClr val="1A1A1A"/>
-                </a:solidFill>
+              <a:rPr sz="2500" b="1">
                 <a:latin typeface="Malgun Gothic"/>
               </a:rPr>
               <a:t>테스트 구간 실제값 vs 예측값</a:t>
@@ -3099,13 +3091,13 @@
           <a:p>
             <a:pPr algn="l"/>
             <a:r>
-              <a:rPr sz="1200" b="0">
-                <a:solidFill>
-                  <a:srgbClr val="5C5C5C"/>
+              <a:rPr sz="1150">
+                <a:solidFill>
+                  <a:srgbClr val="4B5563"/>
                 </a:solidFill>
                 <a:latin typeface="Malgun Gothic"/>
               </a:rPr>
-              <a:t>각 시점의 1시간 뒤 대중교통 승차량을 실제값과 예측값으로 비교</a:t>
+              <a:t>모델: HistGradientBoostingRegressor / Target: 1시간 뒤 동별 대중교통 승차량</a:t>
             </a:r>
           </a:p>
         </p:txBody>
@@ -3226,13 +3218,25 @@
           <a:p>
             <a:pPr algn="l"/>
             <a:r>
-              <a:rPr sz="919" b="1">
-                <a:solidFill>
-                  <a:srgbClr val="1A1A1A"/>
+              <a:rPr sz="919">
+                <a:solidFill>
+                  <a:srgbClr val="1F2937"/>
                 </a:solidFill>
                 <a:latin typeface="Malgun Gothic"/>
               </a:rPr>
-              <a:t>해석: x축은 실제 대중교통 승차량, y축은 예측 대중교통 승차량입니다. 점이 대각선에 가까울수록 실제값과 예측값이 가깝습니다.</a:t>
+              <a:t>Test 결과: MAE 165.7명, RMSE 393.7명, R² 0.9854.  x축은 실제 대중교통 승차량, y축은 예측값입니다.</a:t>
+            </a:r>
+          </a:p>
+          <a:p>
+            <a:pPr algn="l"/>
+            <a:r>
+              <a:rPr sz="919">
+                <a:solidFill>
+                  <a:srgbClr val="1F2937"/>
+                </a:solidFill>
+                <a:latin typeface="Malgun Gothic"/>
+              </a:rPr>
+              <a:t>출처: Colab 산출물 transit_test_predictions.csv / transit_model_metrics.json</a:t>
             </a:r>
           </a:p>
         </p:txBody>
@@ -3450,9 +3454,6 @@
             <a:pPr algn="l"/>
             <a:r>
               <a:rPr sz="2400" b="1">
-                <a:solidFill>
-                  <a:srgbClr val="1A1A1A"/>
-                </a:solidFill>
                 <a:latin typeface="Malgun Gothic"/>
               </a:rPr>
               <a:t>사이트에 붙인 결과와 다음 연결 방향</a:t>
@@ -3635,16 +3636,37 @@
               </a:lnSpc>
             </a:pPr>
             <a:r>
-              <a:rPr sz="1050" b="0">
-                <a:solidFill>
-                  <a:srgbClr val="1F2937"/>
-                </a:solidFill>
+              <a:rPr sz="1040">
                 <a:latin typeface="Malgun Gothic"/>
               </a:rPr>
-              <a:t>• 메인 지도 상단에 발표 자료 버튼 추가
-• /presentation에 데이터 출처와 모델 결과 정리
-• PPT 다운로드 링크 연결
-• Cloudflare 배포용 asset은 가볍게 유지</a:t>
+              <a:t>• 메인 지도 상단에 발표 자료 버튼 추가</a:t>
+            </a:r>
+          </a:p>
+          <a:p>
+            <a:pPr algn="l"/>
+            <a:r>
+              <a:rPr sz="1040">
+                <a:latin typeface="Malgun Gothic"/>
+              </a:rPr>
+              <a:t>• /presentation에 데이터 출처와 모델 결과 정리</a:t>
+            </a:r>
+          </a:p>
+          <a:p>
+            <a:pPr algn="l"/>
+            <a:r>
+              <a:rPr sz="1040">
+                <a:latin typeface="Malgun Gothic"/>
+              </a:rPr>
+              <a:t>• PPT 다운로드 링크 연결</a:t>
+            </a:r>
+          </a:p>
+          <a:p>
+            <a:pPr algn="l"/>
+            <a:r>
+              <a:rPr sz="1040">
+                <a:latin typeface="Malgun Gothic"/>
+              </a:rPr>
+              <a:t>• Cloudflare 배포용 asset은 가볍게 유지</a:t>
             </a:r>
           </a:p>
         </p:txBody>
@@ -3712,15 +3734,74 @@
               </a:lnSpc>
             </a:pPr>
             <a:r>
-              <a:rPr sz="1050" b="0">
-                <a:solidFill>
-                  <a:srgbClr val="1F2937"/>
-                </a:solidFill>
+              <a:rPr sz="1040">
                 <a:latin typeface="Malgun Gothic"/>
               </a:rPr>
-              <a:t>• 지도 위 동별 수요 색상/랭킹 overlay
-• 실시간 citydata와 예측값을 함께 표시
-• 실제 호출 데이터 확보 시 proxy 보정</a:t>
+              <a:t>• 지도 위 동별 수요 색상/랭킹 overlay</a:t>
+            </a:r>
+          </a:p>
+          <a:p>
+            <a:pPr algn="l"/>
+            <a:r>
+              <a:rPr sz="1040">
+                <a:latin typeface="Malgun Gothic"/>
+              </a:rPr>
+              <a:t>• 실시간 citydata와 예측값을 함께 표시</a:t>
+            </a:r>
+          </a:p>
+          <a:p>
+            <a:pPr algn="l"/>
+            <a:r>
+              <a:rPr sz="1040">
+                <a:latin typeface="Malgun Gothic"/>
+              </a:rPr>
+              <a:t>• 실제 택시 호출 데이터 확보 시 proxy 보정</a:t>
+            </a:r>
+          </a:p>
+        </p:txBody>
+      </p:sp>
+      <p:sp>
+        <p:nvSpPr>
+          <p:cNvPr id="14" name="TextBox 13"/>
+          <p:cNvSpPr txBox="1"/>
+          <p:nvPr/>
+        </p:nvSpPr>
+        <p:spPr>
+          <a:xfrm>
+            <a:off x="411480" y="4350000"/>
+            <a:ext cx="4389120" cy="420000"/>
+          </a:xfrm>
+          <a:prstGeom prst="rect">
+            <a:avLst/>
+          </a:prstGeom>
+          <a:noFill/>
+        </p:spPr>
+        <p:txBody>
+          <a:bodyPr wrap="none">
+            <a:spAutoFit/>
+          </a:bodyPr>
+          <a:lstStyle/>
+          <a:p>
+            <a:pPr/>
+            <a:r>
+              <a:rPr sz="869">
+                <a:solidFill>
+                  <a:srgbClr val="4B5563"/>
+                </a:solidFill>
+                <a:latin typeface="Malgun Gothic"/>
+              </a:rPr>
+              <a:t>이미지 설명: Colab 결과를 발표용으로 정리한 웹 화면입니다.</a:t>
+            </a:r>
+          </a:p>
+          <a:p>
+            <a:r>
+              <a:rPr sz="869">
+                <a:solidFill>
+                  <a:srgbClr val="4B5563"/>
+                </a:solidFill>
+                <a:latin typeface="Malgun Gothic"/>
+              </a:rPr>
+              <a:t>현재 예측값은 실제 택시 호출량이 아니라 대중교통 승차량 기반 proxy입니다.</a:t>
             </a:r>
           </a:p>
         </p:txBody>
@@ -3937,10 +4018,7 @@
           <a:p>
             <a:pPr algn="l"/>
             <a:r>
-              <a:rPr sz="2400" b="1">
-                <a:solidFill>
-                  <a:srgbClr val="1A1A1A"/>
-                </a:solidFill>
+              <a:rPr sz="2500" b="1">
                 <a:latin typeface="Malgun Gothic"/>
               </a:rPr>
               <a:t>한계와 다음 개선점</a:t>
@@ -4143,15 +4221,28 @@
               </a:lnSpc>
             </a:pPr>
             <a:r>
-              <a:rPr sz="1050" b="0">
-                <a:solidFill>
-                  <a:srgbClr val="1F2937"/>
-                </a:solidFill>
+              <a:rPr sz="1060">
                 <a:latin typeface="Malgun Gothic"/>
               </a:rPr>
-              <a:t>• 실제 택시 호출량 데이터가 아님
-• 대중교통 수요와 택시 수요는 완전히 같지 않음
-• 현재 결과는 이동 수요 proxy로 해석해야 함</a:t>
+              <a:t>• 실제 택시 호출량 데이터가 아님</a:t>
+            </a:r>
+          </a:p>
+          <a:p>
+            <a:pPr algn="l"/>
+            <a:r>
+              <a:rPr sz="1060">
+                <a:latin typeface="Malgun Gothic"/>
+              </a:rPr>
+              <a:t>• 대중교통 수요와 택시 수요는 완전히 같지 않음</a:t>
+            </a:r>
+          </a:p>
+          <a:p>
+            <a:pPr algn="l"/>
+            <a:r>
+              <a:rPr sz="1060">
+                <a:latin typeface="Malgun Gothic"/>
+              </a:rPr>
+              <a:t>• 현재 결과는 이동 수요 proxy로 해석해야 함</a:t>
             </a:r>
           </a:p>
         </p:txBody>
@@ -4351,15 +4442,28 @@
               </a:lnSpc>
             </a:pPr>
             <a:r>
-              <a:rPr sz="1050" b="0">
-                <a:solidFill>
-                  <a:srgbClr val="1F2937"/>
-                </a:solidFill>
+              <a:rPr sz="1060">
                 <a:latin typeface="Malgun Gothic"/>
               </a:rPr>
-              <a:t>• 실제 호출/승하차 데이터 확보 시 보정
-• 5분·15분 단위 예측으로 확장
-• 지도에서 수요와 신뢰도를 함께 표시</a:t>
+              <a:t>• 실제 호출/승하차 데이터 확보 시 보정</a:t>
+            </a:r>
+          </a:p>
+          <a:p>
+            <a:pPr algn="l"/>
+            <a:r>
+              <a:rPr sz="1060">
+                <a:latin typeface="Malgun Gothic"/>
+              </a:rPr>
+              <a:t>• 5분·15분 단위 예측으로 확장</a:t>
+            </a:r>
+          </a:p>
+          <a:p>
+            <a:pPr algn="l"/>
+            <a:r>
+              <a:rPr sz="1060">
+                <a:latin typeface="Malgun Gothic"/>
+              </a:rPr>
+              <a:t>• 지도에서 수요와 신뢰도를 함께 표시</a:t>
             </a:r>
           </a:p>
         </p:txBody>
@@ -4758,15 +4862,10 @@
               <a:buNone/>
             </a:pPr>
             <a:r>
-              <a:rPr lang="en-US" sz="1400" dirty="0">
-                <a:solidFill>
-                  <a:srgbClr val="FFCD00"/>
-                </a:solidFill>
-                <a:latin typeface="Arial" pitchFamily="34" charset="0"/>
-                <a:ea typeface="Arial" pitchFamily="34" charset="-122"/>
-                <a:cs typeface="Arial" pitchFamily="34" charset="-120"/>
-              </a:rPr>
-              <a:t>역삼동 · Digital Twin · 택시 수요 예측</a:t>
+              <a:rPr sz="1700">
+                <a:latin typeface="Malgun Gothic"/>
+              </a:rPr>
+              <a:t>역삼동 · Digital Twin · 이동 수요 proxy 예측</a:t>
             </a:r>
             <a:endParaRPr lang="en-US" sz="1400" dirty="0"/>
           </a:p>
@@ -5100,15 +5199,10 @@
               <a:buNone/>
             </a:pPr>
             <a:r>
-              <a:rPr lang="en-US" sz="3000" b="1" dirty="0">
-                <a:solidFill>
-                  <a:srgbClr val="1A1A1A"/>
-                </a:solidFill>
-                <a:latin typeface="Arial Black" pitchFamily="34" charset="0"/>
-                <a:ea typeface="Arial Black" pitchFamily="34" charset="-122"/>
-                <a:cs typeface="Arial Black" pitchFamily="34" charset="-120"/>
-              </a:rPr>
-              <a:t>발표 순서</a:t>
+              <a:rPr sz="2800" b="1">
+                <a:latin typeface="Malgun Gothic"/>
+              </a:rPr>
+              <a:t>발표 흐름</a:t>
             </a:r>
             <a:endParaRPr lang="en-US" sz="3000" dirty="0"/>
           </a:p>
@@ -5235,15 +5329,10 @@
               <a:buNone/>
             </a:pPr>
             <a:r>
-              <a:rPr lang="en-US" sz="1400" b="1" dirty="0">
-                <a:solidFill>
-                  <a:srgbClr val="FFFFFF"/>
-                </a:solidFill>
-                <a:latin typeface="Arial" pitchFamily="34" charset="0"/>
-                <a:ea typeface="Arial" pitchFamily="34" charset="-122"/>
-                <a:cs typeface="Arial" pitchFamily="34" charset="-120"/>
-              </a:rPr>
-              <a:t>프로젝트 개요</a:t>
+              <a:rPr sz="1500" b="1">
+                <a:latin typeface="Malgun Gothic"/>
+              </a:rPr>
+              <a:t>프로젝트 개요·변경점</a:t>
             </a:r>
             <a:endParaRPr lang="en-US" sz="1400" dirty="0"/>
           </a:p>
@@ -5274,15 +5363,10 @@
               <a:buNone/>
             </a:pPr>
             <a:r>
-              <a:rPr lang="en-US" sz="1100" dirty="0">
-                <a:solidFill>
-                  <a:srgbClr val="5C5C5C"/>
-                </a:solidFill>
-                <a:latin typeface="Arial" pitchFamily="34" charset="0"/>
-                <a:ea typeface="Arial" pitchFamily="34" charset="-122"/>
-                <a:cs typeface="Arial" pitchFamily="34" charset="-120"/>
-              </a:rPr>
-              <a:t>미션 목표 &amp; 팀 접근 방식</a:t>
+              <a:rPr sz="1050">
+                <a:latin typeface="Malgun Gothic"/>
+              </a:rPr>
+              <a:t>1~4: 문제 정의와 명세서 대비 변경</a:t>
             </a:r>
             <a:endParaRPr lang="en-US" sz="1100" dirty="0"/>
           </a:p>
@@ -5409,15 +5493,10 @@
               <a:buNone/>
             </a:pPr>
             <a:r>
-              <a:rPr lang="en-US" sz="1400" b="1" dirty="0">
-                <a:solidFill>
-                  <a:srgbClr val="1A1A1A"/>
-                </a:solidFill>
-                <a:latin typeface="Arial" pitchFamily="34" charset="0"/>
-                <a:ea typeface="Arial" pitchFamily="34" charset="-122"/>
-                <a:cs typeface="Arial" pitchFamily="34" charset="-120"/>
-              </a:rPr>
-              <a:t>명세서 대비 변경 사항</a:t>
+              <a:rPr sz="1500" b="1">
+                <a:latin typeface="Malgun Gothic"/>
+              </a:rPr>
+              <a:t>웹 구현·배포</a:t>
             </a:r>
             <a:endParaRPr lang="en-US" sz="1400" dirty="0"/>
           </a:p>
@@ -5448,15 +5527,10 @@
               <a:buNone/>
             </a:pPr>
             <a:r>
-              <a:rPr lang="en-US" sz="1100" dirty="0">
-                <a:solidFill>
-                  <a:srgbClr val="5C5C5C"/>
-                </a:solidFill>
-                <a:latin typeface="Arial" pitchFamily="34" charset="0"/>
-                <a:ea typeface="Arial" pitchFamily="34" charset="-122"/>
-                <a:cs typeface="Arial" pitchFamily="34" charset="-120"/>
-              </a:rPr>
-              <a:t>우리가 다르게 구현한 이유</a:t>
+              <a:rPr sz="1050">
+                <a:latin typeface="Malgun Gothic"/>
+              </a:rPr>
+              <a:t>5~8: Three.js·OSM·Cloudflare</a:t>
             </a:r>
             <a:endParaRPr lang="en-US" sz="1100" dirty="0"/>
           </a:p>
@@ -5583,15 +5657,10 @@
               <a:buNone/>
             </a:pPr>
             <a:r>
-              <a:rPr lang="en-US" sz="1400" b="1" dirty="0">
-                <a:solidFill>
-                  <a:srgbClr val="FFFFFF"/>
-                </a:solidFill>
-                <a:latin typeface="Arial" pitchFamily="34" charset="0"/>
-                <a:ea typeface="Arial" pitchFamily="34" charset="-122"/>
-                <a:cs typeface="Arial" pitchFamily="34" charset="-120"/>
-              </a:rPr>
-              <a:t>기술 스택 &amp; 구현</a:t>
+              <a:rPr sz="1500" b="1">
+                <a:latin typeface="Malgun Gothic"/>
+              </a:rPr>
+              <a:t>데이터 수집·학습</a:t>
             </a:r>
             <a:endParaRPr lang="en-US" sz="1400" dirty="0"/>
           </a:p>
@@ -5622,15 +5691,10 @@
               <a:buNone/>
             </a:pPr>
             <a:r>
-              <a:rPr lang="en-US" sz="1100" dirty="0">
-                <a:solidFill>
-                  <a:srgbClr val="5C5C5C"/>
-                </a:solidFill>
-                <a:latin typeface="Arial" pitchFamily="34" charset="0"/>
-                <a:ea typeface="Arial" pitchFamily="34" charset="-122"/>
-                <a:cs typeface="Arial" pitchFamily="34" charset="-120"/>
-              </a:rPr>
-              <a:t>Three.js · OSM · Cloudflare</a:t>
+              <a:rPr sz="1050">
+                <a:latin typeface="Malgun Gothic"/>
+              </a:rPr>
+              <a:t>9~11: 공개 데이터와 Colab 모델</a:t>
             </a:r>
             <a:endParaRPr lang="en-US" sz="1100" dirty="0"/>
           </a:p>
@@ -5757,15 +5821,10 @@
               <a:buNone/>
             </a:pPr>
             <a:r>
-              <a:rPr lang="en-US" sz="1400" b="1" dirty="0">
-                <a:solidFill>
-                  <a:srgbClr val="1A1A1A"/>
-                </a:solidFill>
-                <a:latin typeface="Arial" pitchFamily="34" charset="0"/>
-                <a:ea typeface="Arial" pitchFamily="34" charset="-122"/>
-                <a:cs typeface="Arial" pitchFamily="34" charset="-120"/>
-              </a:rPr>
-              <a:t>모듈별 결과</a:t>
+              <a:rPr sz="1500" b="1">
+                <a:latin typeface="Malgun Gothic"/>
+              </a:rPr>
+              <a:t>서비스 연결·다음 단계</a:t>
             </a:r>
             <a:endParaRPr lang="en-US" sz="1400" dirty="0"/>
           </a:p>
@@ -5796,15 +5855,10 @@
               <a:buNone/>
             </a:pPr>
             <a:r>
-              <a:rPr lang="en-US" sz="1100" dirty="0">
-                <a:solidFill>
-                  <a:srgbClr val="5C5C5C"/>
-                </a:solidFill>
-                <a:latin typeface="Arial" pitchFamily="34" charset="0"/>
-                <a:ea typeface="Arial" pitchFamily="34" charset="-122"/>
-                <a:cs typeface="Arial" pitchFamily="34" charset="-120"/>
-              </a:rPr>
-              <a:t>시뮬레이션 · 예측 · 배차</a:t>
+              <a:rPr sz="1050">
+                <a:latin typeface="Malgun Gothic"/>
+              </a:rPr>
+              <a:t>12~14: 사이트 반영과 개선 계획</a:t>
             </a:r>
             <a:endParaRPr lang="en-US" sz="1100" dirty="0"/>
           </a:p>
@@ -6180,51 +6234,30 @@
               <a:buNone/>
             </a:pPr>
             <a:r>
-              <a:rPr lang="en-US" sz="1200" dirty="0">
-                <a:solidFill>
-                  <a:srgbClr val="5C5C5C"/>
-                </a:solidFill>
-                <a:latin typeface="Arial" pitchFamily="34" charset="0"/>
-                <a:ea typeface="Arial" pitchFamily="34" charset="-122"/>
-                <a:cs typeface="Arial" pitchFamily="34" charset="-120"/>
+              <a:rPr sz="1350">
+                <a:latin typeface="Malgun Gothic"/>
               </a:rPr>
               <a:t>역삼동 실제 도로망을</a:t>
             </a:r>
             <a:endParaRPr lang="en-US" sz="1200" dirty="0"/>
           </a:p>
           <a:p>
-            <a:pPr marL="0" indent="0" algn="ctr">
-              <a:buNone/>
-            </a:pPr>
-            <a:r>
-              <a:rPr lang="en-US" sz="1200" dirty="0">
-                <a:solidFill>
-                  <a:srgbClr val="5C5C5C"/>
-                </a:solidFill>
-                <a:latin typeface="Arial" pitchFamily="34" charset="0"/>
-                <a:ea typeface="Arial" pitchFamily="34" charset="-122"/>
-                <a:cs typeface="Arial" pitchFamily="34" charset="-120"/>
+            <a:pPr algn="ctr"/>
+            <a:r>
+              <a:rPr sz="1350">
+                <a:latin typeface="Malgun Gothic"/>
               </a:rPr>
               <a:t>3D로 가상화한 환경에서</a:t>
             </a:r>
-            <a:endParaRPr lang="en-US" sz="1200" dirty="0"/>
-          </a:p>
-          <a:p>
-            <a:pPr marL="0" indent="0" algn="ctr">
-              <a:buNone/>
-            </a:pPr>
-            <a:r>
-              <a:rPr lang="en-US" sz="1200" dirty="0">
-                <a:solidFill>
-                  <a:srgbClr val="5C5C5C"/>
-                </a:solidFill>
-                <a:latin typeface="Arial" pitchFamily="34" charset="0"/>
-                <a:ea typeface="Arial" pitchFamily="34" charset="-122"/>
-                <a:cs typeface="Arial" pitchFamily="34" charset="-120"/>
-              </a:rPr>
-              <a:t>택시 수요·배차 시뮬레이션</a:t>
-            </a:r>
-            <a:endParaRPr lang="en-US" sz="1200" dirty="0"/>
+          </a:p>
+          <a:p>
+            <a:pPr algn="ctr"/>
+            <a:r>
+              <a:rPr sz="1350">
+                <a:latin typeface="Malgun Gothic"/>
+              </a:rPr>
+              <a:t>이동 수요·배차 시뮬레이션</a:t>
+            </a:r>
           </a:p>
         </p:txBody>
       </p:sp>
@@ -6398,51 +6431,30 @@
               <a:buNone/>
             </a:pPr>
             <a:r>
-              <a:rPr lang="en-US" sz="1200" dirty="0">
-                <a:solidFill>
-                  <a:srgbClr val="5C5C5C"/>
-                </a:solidFill>
-                <a:latin typeface="Arial" pitchFamily="34" charset="0"/>
-                <a:ea typeface="Arial" pitchFamily="34" charset="-122"/>
-                <a:cs typeface="Arial" pitchFamily="34" charset="-120"/>
-              </a:rPr>
-              <a:t>시공간 피처 기반</a:t>
+              <a:rPr sz="1300">
+                <a:latin typeface="Malgun Gothic"/>
+              </a:rPr>
+              <a:t>대중교통 승차량 기반</a:t>
             </a:r>
             <a:endParaRPr lang="en-US" sz="1200" dirty="0"/>
           </a:p>
           <a:p>
-            <a:pPr marL="0" indent="0" algn="ctr">
-              <a:buNone/>
-            </a:pPr>
-            <a:r>
-              <a:rPr lang="en-US" sz="1200" dirty="0">
-                <a:solidFill>
-                  <a:srgbClr val="5C5C5C"/>
-                </a:solidFill>
-                <a:latin typeface="Arial" pitchFamily="34" charset="0"/>
-                <a:ea typeface="Arial" pitchFamily="34" charset="-122"/>
-                <a:cs typeface="Arial" pitchFamily="34" charset="-120"/>
-              </a:rPr>
-              <a:t>LSTM/ConvLSTM 모델로</a:t>
-            </a:r>
-            <a:endParaRPr lang="en-US" sz="1200" dirty="0"/>
-          </a:p>
-          <a:p>
-            <a:pPr marL="0" indent="0" algn="ctr">
-              <a:buNone/>
-            </a:pPr>
-            <a:r>
-              <a:rPr lang="en-US" sz="1200" dirty="0">
-                <a:solidFill>
-                  <a:srgbClr val="5C5C5C"/>
-                </a:solidFill>
-                <a:latin typeface="Arial" pitchFamily="34" charset="0"/>
-                <a:ea typeface="Arial" pitchFamily="34" charset="-122"/>
-                <a:cs typeface="Arial" pitchFamily="34" charset="-120"/>
-              </a:rPr>
-              <a:t>30분 단위 호출 수 예측</a:t>
-            </a:r>
-            <a:endParaRPr lang="en-US" sz="1200" dirty="0"/>
+            <a:pPr algn="ctr"/>
+            <a:r>
+              <a:rPr sz="1300">
+                <a:latin typeface="Malgun Gothic"/>
+              </a:rPr>
+              <a:t>HistGradientBoosting 모델로</a:t>
+            </a:r>
+          </a:p>
+          <a:p>
+            <a:pPr algn="ctr"/>
+            <a:r>
+              <a:rPr sz="1300">
+                <a:latin typeface="Malgun Gothic"/>
+              </a:rPr>
+              <a:t>1시간 뒤 이동 수요 proxy 예측</a:t>
+            </a:r>
           </a:p>
         </p:txBody>
       </p:sp>
@@ -6577,15 +6589,10 @@
               <a:buNone/>
             </a:pPr>
             <a:r>
-              <a:rPr lang="en-US" sz="1600" b="1" dirty="0">
-                <a:solidFill>
-                  <a:srgbClr val="1A1A1A"/>
-                </a:solidFill>
-                <a:latin typeface="Arial Black" pitchFamily="34" charset="0"/>
-                <a:ea typeface="Arial Black" pitchFamily="34" charset="-122"/>
-                <a:cs typeface="Arial Black" pitchFamily="34" charset="-120"/>
-              </a:rPr>
-              <a:t>동적 배차</a:t>
+              <a:rPr sz="1800" b="1">
+                <a:latin typeface="Malgun Gothic"/>
+              </a:rPr>
+              <a:t>배차 연결</a:t>
             </a:r>
             <a:endParaRPr lang="en-US" sz="1600" dirty="0"/>
           </a:p>
@@ -6616,51 +6623,30 @@
               <a:buNone/>
             </a:pPr>
             <a:r>
-              <a:rPr lang="en-US" sz="1200" dirty="0">
-                <a:solidFill>
-                  <a:srgbClr val="5C5C5C"/>
-                </a:solidFill>
-                <a:latin typeface="Arial" pitchFamily="34" charset="0"/>
-                <a:ea typeface="Arial" pitchFamily="34" charset="-122"/>
-                <a:cs typeface="Arial" pitchFamily="34" charset="-120"/>
-              </a:rPr>
-              <a:t>수급 불균형 지표 계산 후</a:t>
+              <a:rPr sz="1300">
+                <a:latin typeface="Malgun Gothic"/>
+              </a:rPr>
+              <a:t>동별 수요 신호를 지도에 연결하고</a:t>
             </a:r>
             <a:endParaRPr lang="en-US" sz="1200" dirty="0"/>
           </a:p>
           <a:p>
-            <a:pPr marL="0" indent="0" algn="ctr">
-              <a:buNone/>
-            </a:pPr>
-            <a:r>
-              <a:rPr lang="en-US" sz="1200" dirty="0">
-                <a:solidFill>
-                  <a:srgbClr val="5C5C5C"/>
-                </a:solidFill>
-                <a:latin typeface="Arial" pitchFamily="34" charset="0"/>
-                <a:ea typeface="Arial" pitchFamily="34" charset="-122"/>
-                <a:cs typeface="Arial" pitchFamily="34" charset="-120"/>
-              </a:rPr>
-              <a:t>Surge Pricing 인센티브로</a:t>
-            </a:r>
-            <a:endParaRPr lang="en-US" sz="1200" dirty="0"/>
-          </a:p>
-          <a:p>
-            <a:pPr marL="0" indent="0" algn="ctr">
-              <a:buNone/>
-            </a:pPr>
-            <a:r>
-              <a:rPr lang="en-US" sz="1200" dirty="0">
-                <a:solidFill>
-                  <a:srgbClr val="5C5C5C"/>
-                </a:solidFill>
-                <a:latin typeface="Arial" pitchFamily="34" charset="0"/>
-                <a:ea typeface="Arial" pitchFamily="34" charset="-122"/>
-                <a:cs typeface="Arial" pitchFamily="34" charset="-120"/>
-              </a:rPr>
-              <a:t>빈 택시를 수요지로 유도</a:t>
-            </a:r>
-            <a:endParaRPr lang="en-US" sz="1200" dirty="0"/>
+            <a:pPr algn="ctr"/>
+            <a:r>
+              <a:rPr sz="1300">
+                <a:latin typeface="Malgun Gothic"/>
+              </a:rPr>
+              <a:t>향후 실제 호출 데이터 확보 시</a:t>
+            </a:r>
+          </a:p>
+          <a:p>
+            <a:pPr algn="ctr"/>
+            <a:r>
+              <a:rPr sz="1300">
+                <a:latin typeface="Malgun Gothic"/>
+              </a:rPr>
+              <a:t>배차 정책으로 확장</a:t>
+            </a:r>
           </a:p>
         </p:txBody>
       </p:sp>
@@ -7186,15 +7172,10 @@
               <a:buNone/>
             </a:pPr>
             <a:r>
-              <a:rPr lang="en-US" sz="1000" dirty="0">
-                <a:solidFill>
-                  <a:srgbClr val="5C5C5C"/>
-                </a:solidFill>
-                <a:latin typeface="Arial" pitchFamily="34" charset="0"/>
-                <a:ea typeface="Arial" pitchFamily="34" charset="-122"/>
-                <a:cs typeface="Arial" pitchFamily="34" charset="-120"/>
-              </a:rPr>
-              <a:t>실제 카카오T 수요가 집중되는 지역을 반영, 의미 있는 예측 가능</a:t>
+              <a:rPr sz="1050">
+                <a:latin typeface="Malgun Gothic"/>
+              </a:rPr>
+              <a:t>상업·업무 밀집 지역 특성을 반영해 더 현실적인 실험 가능</a:t>
             </a:r>
             <a:endParaRPr lang="en-US" sz="1000" dirty="0"/>
           </a:p>
@@ -10658,13 +10639,8 @@
               <a:buNone/>
             </a:pPr>
             <a:r>
-              <a:rPr lang="en-US" sz="2600" b="1" dirty="0">
-                <a:solidFill>
-                  <a:srgbClr val="1A1A1A"/>
-                </a:solidFill>
-                <a:latin typeface="Arial Black" pitchFamily="34" charset="0"/>
-                <a:ea typeface="Arial Black" pitchFamily="34" charset="-122"/>
-                <a:cs typeface="Arial Black" pitchFamily="34" charset="-120"/>
+              <a:rPr sz="2600" b="1">
+                <a:latin typeface="Malgun Gothic"/>
               </a:rPr>
               <a:t>4개 모듈 통합 아키텍처</a:t>
             </a:r>
@@ -11065,34 +11041,21 @@
               <a:buNone/>
             </a:pPr>
             <a:r>
-              <a:rPr lang="en-US" sz="1400" b="1" dirty="0">
-                <a:solidFill>
-                  <a:srgbClr val="FFFFFF"/>
-                </a:solidFill>
-                <a:latin typeface="Arial" pitchFamily="34" charset="0"/>
-                <a:ea typeface="Arial" pitchFamily="34" charset="-122"/>
-                <a:cs typeface="Arial" pitchFamily="34" charset="-120"/>
-              </a:rPr>
-              <a:t>시공간 데이터</a:t>
+              <a:rPr sz="1700" b="1">
+                <a:latin typeface="Malgun Gothic"/>
+              </a:rPr>
+              <a:t>공개 데이터</a:t>
             </a:r>
             <a:endParaRPr lang="en-US" sz="1400" dirty="0"/>
           </a:p>
           <a:p>
-            <a:pPr marL="0" indent="0" algn="ctr">
-              <a:buNone/>
-            </a:pPr>
-            <a:r>
-              <a:rPr lang="en-US" sz="1400" b="1" dirty="0">
-                <a:solidFill>
-                  <a:srgbClr val="FFFFFF"/>
-                </a:solidFill>
-                <a:latin typeface="Arial" pitchFamily="34" charset="0"/>
-                <a:ea typeface="Arial" pitchFamily="34" charset="-122"/>
-                <a:cs typeface="Arial" pitchFamily="34" charset="-120"/>
+            <a:pPr algn="ctr"/>
+            <a:r>
+              <a:rPr sz="1700" b="1">
+                <a:latin typeface="Malgun Gothic"/>
               </a:rPr>
               <a:t>전처리</a:t>
             </a:r>
-            <a:endParaRPr lang="en-US" sz="1400" dirty="0"/>
           </a:p>
         </p:txBody>
       </p:sp>
@@ -11146,34 +11109,21 @@
               <a:buNone/>
             </a:pPr>
             <a:r>
-              <a:rPr lang="en-US" sz="1100" dirty="0">
-                <a:solidFill>
-                  <a:srgbClr val="CCCCCC"/>
-                </a:solidFill>
-                <a:latin typeface="Arial" pitchFamily="34" charset="0"/>
-                <a:ea typeface="Arial" pitchFamily="34" charset="-122"/>
-                <a:cs typeface="Arial" pitchFamily="34" charset="-120"/>
-              </a:rPr>
-              <a:t>GPS→H3 격자</a:t>
+              <a:rPr sz="1150">
+                <a:latin typeface="Malgun Gothic"/>
+              </a:rPr>
+              <a:t>행정동·시간대 정렬</a:t>
             </a:r>
             <a:endParaRPr lang="en-US" sz="1100" dirty="0"/>
           </a:p>
           <a:p>
-            <a:pPr marL="0" indent="0" algn="ctr">
-              <a:buNone/>
-            </a:pPr>
-            <a:r>
-              <a:rPr lang="en-US" sz="1100" dirty="0">
-                <a:solidFill>
-                  <a:srgbClr val="CCCCCC"/>
-                </a:solidFill>
-                <a:latin typeface="Arial" pitchFamily="34" charset="0"/>
-                <a:ea typeface="Arial" pitchFamily="34" charset="-122"/>
-                <a:cs typeface="Arial" pitchFamily="34" charset="-120"/>
-              </a:rPr>
-              <a:t>Lag Feature 생성</a:t>
-            </a:r>
-            <a:endParaRPr lang="en-US" sz="1100" dirty="0"/>
+            <a:pPr algn="ctr"/>
+            <a:r>
+              <a:rPr sz="1150">
+                <a:latin typeface="Malgun Gothic"/>
+              </a:rPr>
+              <a:t>날씨·휴일·Lag Feature 생성</a:t>
+            </a:r>
           </a:p>
         </p:txBody>
       </p:sp>
@@ -11337,34 +11287,21 @@
               <a:buNone/>
             </a:pPr>
             <a:r>
-              <a:rPr lang="en-US" sz="1400" b="1" dirty="0">
-                <a:solidFill>
-                  <a:srgbClr val="FFFFFF"/>
-                </a:solidFill>
-                <a:latin typeface="Arial" pitchFamily="34" charset="0"/>
-                <a:ea typeface="Arial" pitchFamily="34" charset="-122"/>
-                <a:cs typeface="Arial" pitchFamily="34" charset="-120"/>
-              </a:rPr>
-              <a:t>수요 예측</a:t>
+              <a:rPr sz="1650" b="1">
+                <a:latin typeface="Malgun Gothic"/>
+              </a:rPr>
+              <a:t>이동 수요 proxy</a:t>
             </a:r>
             <a:endParaRPr lang="en-US" sz="1400" dirty="0"/>
           </a:p>
           <a:p>
-            <a:pPr marL="0" indent="0" algn="ctr">
-              <a:buNone/>
-            </a:pPr>
-            <a:r>
-              <a:rPr lang="en-US" sz="1400" b="1" dirty="0">
-                <a:solidFill>
-                  <a:srgbClr val="FFFFFF"/>
-                </a:solidFill>
-                <a:latin typeface="Arial" pitchFamily="34" charset="0"/>
-                <a:ea typeface="Arial" pitchFamily="34" charset="-122"/>
-                <a:cs typeface="Arial" pitchFamily="34" charset="-120"/>
-              </a:rPr>
-              <a:t>모델</a:t>
-            </a:r>
-            <a:endParaRPr lang="en-US" sz="1400" dirty="0"/>
+            <a:pPr algn="ctr"/>
+            <a:r>
+              <a:rPr sz="1650" b="1">
+                <a:latin typeface="Malgun Gothic"/>
+              </a:rPr>
+              <a:t>예측 모델</a:t>
+            </a:r>
           </a:p>
         </p:txBody>
       </p:sp>
@@ -11418,34 +11355,21 @@
               <a:buNone/>
             </a:pPr>
             <a:r>
-              <a:rPr lang="en-US" sz="1100" dirty="0">
-                <a:solidFill>
-                  <a:srgbClr val="CCCCCC"/>
-                </a:solidFill>
-                <a:latin typeface="Arial" pitchFamily="34" charset="0"/>
-                <a:ea typeface="Arial" pitchFamily="34" charset="-122"/>
-                <a:cs typeface="Arial" pitchFamily="34" charset="-120"/>
-              </a:rPr>
-              <a:t>ConvLSTM</a:t>
+              <a:rPr sz="1150">
+                <a:latin typeface="Malgun Gothic"/>
+              </a:rPr>
+              <a:t>HistGradientBoosting</a:t>
             </a:r>
             <a:endParaRPr lang="en-US" sz="1100" dirty="0"/>
           </a:p>
           <a:p>
-            <a:pPr marL="0" indent="0" algn="ctr">
-              <a:buNone/>
-            </a:pPr>
-            <a:r>
-              <a:rPr lang="en-US" sz="1100" dirty="0">
-                <a:solidFill>
-                  <a:srgbClr val="CCCCCC"/>
-                </a:solidFill>
-                <a:latin typeface="Arial" pitchFamily="34" charset="0"/>
-                <a:ea typeface="Arial" pitchFamily="34" charset="-122"/>
-                <a:cs typeface="Arial" pitchFamily="34" charset="-120"/>
-              </a:rPr>
-              <a:t>RMSE/MAPE 평가</a:t>
-            </a:r>
-            <a:endParaRPr lang="en-US" sz="1100" dirty="0"/>
+            <a:pPr algn="ctr"/>
+            <a:r>
+              <a:rPr sz="1150">
+                <a:latin typeface="Malgun Gothic"/>
+              </a:rPr>
+              <a:t>MAE 165.7 · R² 0.985</a:t>
+            </a:r>
           </a:p>
         </p:txBody>
       </p:sp>
@@ -11609,34 +11533,21 @@
               <a:buNone/>
             </a:pPr>
             <a:r>
-              <a:rPr lang="en-US" sz="1400" b="1" dirty="0">
-                <a:solidFill>
-                  <a:srgbClr val="FFFFFF"/>
-                </a:solidFill>
-                <a:latin typeface="Arial" pitchFamily="34" charset="0"/>
-                <a:ea typeface="Arial" pitchFamily="34" charset="-122"/>
-                <a:cs typeface="Arial" pitchFamily="34" charset="-120"/>
-              </a:rPr>
-              <a:t>동적 배차</a:t>
+              <a:rPr sz="1700" b="1">
+                <a:latin typeface="Malgun Gothic"/>
+              </a:rPr>
+              <a:t>서비스 연결</a:t>
             </a:r>
             <a:endParaRPr lang="en-US" sz="1400" dirty="0"/>
           </a:p>
           <a:p>
-            <a:pPr marL="0" indent="0" algn="ctr">
-              <a:buNone/>
-            </a:pPr>
-            <a:r>
-              <a:rPr lang="en-US" sz="1400" b="1" dirty="0">
-                <a:solidFill>
-                  <a:srgbClr val="FFFFFF"/>
-                </a:solidFill>
-                <a:latin typeface="Arial" pitchFamily="34" charset="0"/>
-                <a:ea typeface="Arial" pitchFamily="34" charset="-122"/>
-                <a:cs typeface="Arial" pitchFamily="34" charset="-120"/>
-              </a:rPr>
-              <a:t>인센티브</a:t>
-            </a:r>
-            <a:endParaRPr lang="en-US" sz="1400" dirty="0"/>
+            <a:pPr algn="ctr"/>
+            <a:r>
+              <a:rPr sz="1700" b="1">
+                <a:latin typeface="Malgun Gothic"/>
+              </a:rPr>
+              <a:t>지도 시각화</a:t>
+            </a:r>
           </a:p>
         </p:txBody>
       </p:sp>
@@ -11690,34 +11601,21 @@
               <a:buNone/>
             </a:pPr>
             <a:r>
-              <a:rPr lang="en-US" sz="1100" dirty="0">
-                <a:solidFill>
-                  <a:srgbClr val="CCCCCC"/>
-                </a:solidFill>
-                <a:latin typeface="Arial" pitchFamily="34" charset="0"/>
-                <a:ea typeface="Arial" pitchFamily="34" charset="-122"/>
-                <a:cs typeface="Arial" pitchFamily="34" charset="-120"/>
-              </a:rPr>
-              <a:t>Surge 알고리즘</a:t>
+              <a:rPr sz="1130">
+                <a:latin typeface="Malgun Gothic"/>
+              </a:rPr>
+              <a:t>동별 수요 랭킹·색상 overlay</a:t>
             </a:r>
             <a:endParaRPr lang="en-US" sz="1100" dirty="0"/>
           </a:p>
           <a:p>
-            <a:pPr marL="0" indent="0" algn="ctr">
-              <a:buNone/>
-            </a:pPr>
-            <a:r>
-              <a:rPr lang="en-US" sz="1100" dirty="0">
-                <a:solidFill>
-                  <a:srgbClr val="CCCCCC"/>
-                </a:solidFill>
-                <a:latin typeface="Arial" pitchFamily="34" charset="0"/>
-                <a:ea typeface="Arial" pitchFamily="34" charset="-122"/>
-                <a:cs typeface="Arial" pitchFamily="34" charset="-120"/>
-              </a:rPr>
-              <a:t>배차 시뮬레이션</a:t>
-            </a:r>
-            <a:endParaRPr lang="en-US" sz="1100" dirty="0"/>
+            <a:pPr algn="ctr"/>
+            <a:r>
+              <a:rPr sz="1130">
+                <a:latin typeface="Malgun Gothic"/>
+              </a:rPr>
+              <a:t>실제 호출 데이터 확보 시 보정</a:t>
+            </a:r>
           </a:p>
         </p:txBody>
       </p:sp>

</xml_diff>

<commit_message>
Upload final reviewed presentation deck
</commit_message>
<xml_diff>
--- a/public/a-eye-presentation/A-Eye_midterm_data_collection_forecast.pptx
+++ b/public/a-eye-presentation/A-Eye_midterm_data_collection_forecast.pptx
@@ -1629,10 +1629,15 @@
               <a:buNone/>
             </a:pPr>
             <a:r>
-              <a:rPr sz="1300">
-                <a:latin typeface="Malgun Gothic"/>
-              </a:rPr>
-              <a:t>Three.js  ·  OpenStreetMap  ·  Cloudflare Pages  ·  Colab/scikit-learn</a:t>
+              <a:rPr lang="en-US" sz="1100" b="1" dirty="0">
+                <a:solidFill>
+                  <a:srgbClr val="1A1A1A"/>
+                </a:solidFill>
+                <a:latin typeface="Arial" pitchFamily="34" charset="0"/>
+                <a:ea typeface="Arial" pitchFamily="34" charset="-122"/>
+                <a:cs typeface="Arial" pitchFamily="34" charset="-120"/>
+              </a:rPr>
+              <a:t>Three.js  ·  OpenStreetMap  ·  Cloudflare Pages  ·  scikit-learn</a:t>
             </a:r>
             <a:endParaRPr lang="en-US" sz="1100" dirty="0"/>
           </a:p>
@@ -3059,7 +3064,10 @@
           <a:p>
             <a:pPr algn="l"/>
             <a:r>
-              <a:rPr sz="2500" b="1">
+              <a:rPr sz="2400" b="1">
+                <a:solidFill>
+                  <a:srgbClr val="1A1A1A"/>
+                </a:solidFill>
                 <a:latin typeface="Malgun Gothic"/>
               </a:rPr>
               <a:t>테스트 구간 실제값 vs 예측값</a:t>
@@ -3091,13 +3099,13 @@
           <a:p>
             <a:pPr algn="l"/>
             <a:r>
-              <a:rPr sz="1150">
+              <a:rPr sz="1050">
                 <a:solidFill>
                   <a:srgbClr val="4B5563"/>
                 </a:solidFill>
                 <a:latin typeface="Malgun Gothic"/>
               </a:rPr>
-              <a:t>모델: HistGradientBoostingRegressor / Target: 1시간 뒤 동별 대중교통 승차량</a:t>
+              <a:t>Test  MAE 165.7 / RMSE 393.7 / R² 0.985 · 평균 실제값 2,099명 대비 오차 약 166명</a:t>
             </a:r>
           </a:p>
         </p:txBody>
@@ -3224,19 +3232,7 @@
                 </a:solidFill>
                 <a:latin typeface="Malgun Gothic"/>
               </a:rPr>
-              <a:t>Test 결과: MAE 165.7명, RMSE 393.7명, R² 0.9854.  x축은 실제 대중교통 승차량, y축은 예측값입니다.</a:t>
-            </a:r>
-          </a:p>
-          <a:p>
-            <a:pPr algn="l"/>
-            <a:r>
-              <a:rPr sz="919">
-                <a:solidFill>
-                  <a:srgbClr val="1F2937"/>
-                </a:solidFill>
-                <a:latin typeface="Malgun Gothic"/>
-              </a:rPr>
-              <a:t>출처: Colab 산출물 transit_test_predictions.csv / transit_model_metrics.json</a:t>
+              <a:t>해석: x축은 실제 대중교통 승차량, y축은 예측값입니다. 점이 대각선에 가까울수록 실제값과 예측값이 가깝습니다.</a:t>
             </a:r>
           </a:p>
         </p:txBody>
@@ -3454,9 +3450,12 @@
             <a:pPr algn="l"/>
             <a:r>
               <a:rPr sz="2400" b="1">
+                <a:solidFill>
+                  <a:srgbClr val="1A1A1A"/>
+                </a:solidFill>
                 <a:latin typeface="Malgun Gothic"/>
               </a:rPr>
-              <a:t>사이트에 붙인 결과와 다음 연결 방향</a:t>
+              <a:t>현재까지 한 것과 목표 프로토타입</a:t>
             </a:r>
           </a:p>
         </p:txBody>
@@ -3603,7 +3602,7 @@
                 </a:solidFill>
                 <a:latin typeface="Malgun Gothic"/>
               </a:rPr>
-              <a:t>현재 반영</a:t>
+              <a:t>현재 완료</a:t>
             </a:r>
           </a:p>
         </p:txBody>
@@ -3636,37 +3635,16 @@
               </a:lnSpc>
             </a:pPr>
             <a:r>
-              <a:rPr sz="1040">
+              <a:rPr sz="1050" b="0">
+                <a:solidFill>
+                  <a:srgbClr val="1F2937"/>
+                </a:solidFill>
                 <a:latin typeface="Malgun Gothic"/>
               </a:rPr>
-              <a:t>• 메인 지도 상단에 발표 자료 버튼 추가</a:t>
-            </a:r>
-          </a:p>
-          <a:p>
-            <a:pPr algn="l"/>
-            <a:r>
-              <a:rPr sz="1040">
-                <a:latin typeface="Malgun Gothic"/>
-              </a:rPr>
-              <a:t>• /presentation에 데이터 출처와 모델 결과 정리</a:t>
-            </a:r>
-          </a:p>
-          <a:p>
-            <a:pPr algn="l"/>
-            <a:r>
-              <a:rPr sz="1040">
-                <a:latin typeface="Malgun Gothic"/>
-              </a:rPr>
-              <a:t>• PPT 다운로드 링크 연결</a:t>
-            </a:r>
-          </a:p>
-          <a:p>
-            <a:pPr algn="l"/>
-            <a:r>
-              <a:rPr sz="1040">
-                <a:latin typeface="Malgun Gothic"/>
-              </a:rPr>
-              <a:t>• Cloudflare 배포용 asset은 가볍게 유지</a:t>
+              <a:t>• 메인 지도 상단에 발표 자료 버튼 추가
+• /presentation에 데이터 출처와 모델 결과 정리
+• PPT 다운로드 링크 연결
+• Cloudflare 배포용 asset은 가볍게 유지</a:t>
             </a:r>
           </a:p>
         </p:txBody>
@@ -3695,13 +3673,10 @@
           <a:p>
             <a:pPr algn="l"/>
             <a:r>
-              <a:rPr sz="1500" b="1">
-                <a:solidFill>
-                  <a:srgbClr val="3B82F6"/>
-                </a:solidFill>
+              <a:rPr sz="1150" b="1">
                 <a:latin typeface="Malgun Gothic"/>
               </a:rPr>
-              <a:t>다음 단계</a:t>
+              <a:t>목표 프로토타입 (좌측 히트맵)</a:t>
             </a:r>
           </a:p>
         </p:txBody>
@@ -3734,78 +3709,65 @@
               </a:lnSpc>
             </a:pPr>
             <a:r>
-              <a:rPr sz="1040">
+              <a:rPr sz="950">
                 <a:latin typeface="Malgun Gothic"/>
               </a:rPr>
-              <a:t>• 지도 위 동별 수요 색상/랭킹 overlay</a:t>
+              <a:t>• 동별 수요를 색상으로 표현한 히트맵</a:t>
             </a:r>
           </a:p>
           <a:p>
             <a:pPr algn="l"/>
             <a:r>
-              <a:rPr sz="1040">
+              <a:rPr sz="950">
                 <a:latin typeface="Malgun Gothic"/>
               </a:rPr>
-              <a:t>• 실시간 citydata와 예측값을 함께 표시</a:t>
+              <a:t>• 모델 결과 반영 시 역삼1동·논현1동·대치4동 등 상위 수요 표시</a:t>
             </a:r>
           </a:p>
           <a:p>
             <a:pPr algn="l"/>
             <a:r>
-              <a:rPr sz="1040">
+              <a:rPr sz="950">
                 <a:latin typeface="Malgun Gothic"/>
               </a:rPr>
-              <a:t>• 실제 택시 호출 데이터 확보 시 proxy 보정</a:t>
-            </a:r>
-          </a:p>
-        </p:txBody>
-      </p:sp>
-      <p:sp>
-        <p:nvSpPr>
-          <p:cNvPr id="14" name="TextBox 13"/>
-          <p:cNvSpPr txBox="1"/>
-          <p:nvPr/>
-        </p:nvSpPr>
-        <p:spPr>
-          <a:xfrm>
-            <a:off x="411480" y="4350000"/>
-            <a:ext cx="4389120" cy="420000"/>
-          </a:xfrm>
-          <a:prstGeom prst="rect">
-            <a:avLst/>
-          </a:prstGeom>
-          <a:noFill/>
-        </p:spPr>
-        <p:txBody>
-          <a:bodyPr wrap="none">
-            <a:spAutoFit/>
-          </a:bodyPr>
-          <a:lstStyle/>
-          <a:p>
-            <a:pPr/>
-            <a:r>
-              <a:rPr sz="869">
-                <a:solidFill>
-                  <a:srgbClr val="4B5563"/>
-                </a:solidFill>
+              <a:t>• 요일·시간·날씨 조건 반영 예정</a:t>
+            </a:r>
+          </a:p>
+          <a:p>
+            <a:pPr algn="l"/>
+            <a:r>
+              <a:rPr sz="950">
                 <a:latin typeface="Malgun Gothic"/>
               </a:rPr>
-              <a:t>이미지 설명: Colab 결과를 발표용으로 정리한 웹 화면입니다.</a:t>
-            </a:r>
-          </a:p>
-          <a:p>
-            <a:r>
-              <a:rPr sz="869">
-                <a:solidFill>
-                  <a:srgbClr val="4B5563"/>
-                </a:solidFill>
-                <a:latin typeface="Malgun Gothic"/>
-              </a:rPr>
-              <a:t>현재 예측값은 실제 택시 호출량이 아니라 대중교통 승차량 기반 proxy입니다.</a:t>
-            </a:r>
-          </a:p>
-        </p:txBody>
-      </p:sp>
+              <a:t>• 이걸 3D 지도 위에 올리는 게 다음 단계</a:t>
+            </a:r>
+          </a:p>
+        </p:txBody>
+      </p:sp>
+      <p:pic>
+        <p:nvPicPr>
+          <p:cNvPr id="20" name="heatmap"/>
+          <p:cNvPicPr>
+            <a:picLocks noChangeAspect="1"/>
+          </p:cNvPicPr>
+          <p:nvPr/>
+        </p:nvPicPr>
+        <p:blipFill>
+          <a:blip r:embed="rId3"/>
+          <a:stretch>
+            <a:fillRect/>
+          </a:stretch>
+        </p:blipFill>
+        <p:spPr>
+          <a:xfrm>
+            <a:off x="365760" y="1143000"/>
+            <a:ext cx="4114800" cy="2743200"/>
+          </a:xfrm>
+          <a:prstGeom prst="rect">
+            <a:avLst/>
+          </a:prstGeom>
+        </p:spPr>
+      </p:pic>
     </p:spTree>
     <p:extLst>
       <p:ext uri="{BB962C8B-B14F-4D97-AF65-F5344CB8AC3E}">
@@ -4018,7 +3980,10 @@
           <a:p>
             <a:pPr algn="l"/>
             <a:r>
-              <a:rPr sz="2500" b="1">
+              <a:rPr sz="2400" b="1">
+                <a:solidFill>
+                  <a:srgbClr val="1A1A1A"/>
+                </a:solidFill>
                 <a:latin typeface="Malgun Gothic"/>
               </a:rPr>
               <a:t>한계와 다음 개선점</a:t>
@@ -4221,28 +4186,15 @@
               </a:lnSpc>
             </a:pPr>
             <a:r>
-              <a:rPr sz="1060">
+              <a:rPr sz="1050" b="0">
+                <a:solidFill>
+                  <a:srgbClr val="1F2937"/>
+                </a:solidFill>
                 <a:latin typeface="Malgun Gothic"/>
               </a:rPr>
-              <a:t>• 실제 택시 호출량 데이터가 아님</a:t>
-            </a:r>
-          </a:p>
-          <a:p>
-            <a:pPr algn="l"/>
-            <a:r>
-              <a:rPr sz="1060">
-                <a:latin typeface="Malgun Gothic"/>
-              </a:rPr>
-              <a:t>• 대중교통 수요와 택시 수요는 완전히 같지 않음</a:t>
-            </a:r>
-          </a:p>
-          <a:p>
-            <a:pPr algn="l"/>
-            <a:r>
-              <a:rPr sz="1060">
-                <a:latin typeface="Malgun Gothic"/>
-              </a:rPr>
-              <a:t>• 현재 결과는 이동 수요 proxy로 해석해야 함</a:t>
+              <a:t>• 실제 택시 호출량 데이터가 아님
+• 대중교통 수요와 택시 수요는 완전히 같지 않음
+• 현재 결과는 이동 수요 proxy로 해석해야 함</a:t>
             </a:r>
           </a:p>
         </p:txBody>
@@ -4442,28 +4394,15 @@
               </a:lnSpc>
             </a:pPr>
             <a:r>
-              <a:rPr sz="1060">
+              <a:rPr sz="1050" b="0">
+                <a:solidFill>
+                  <a:srgbClr val="1F2937"/>
+                </a:solidFill>
                 <a:latin typeface="Malgun Gothic"/>
               </a:rPr>
-              <a:t>• 실제 호출/승하차 데이터 확보 시 보정</a:t>
-            </a:r>
-          </a:p>
-          <a:p>
-            <a:pPr algn="l"/>
-            <a:r>
-              <a:rPr sz="1060">
-                <a:latin typeface="Malgun Gothic"/>
-              </a:rPr>
-              <a:t>• 5분·15분 단위 예측으로 확장</a:t>
-            </a:r>
-          </a:p>
-          <a:p>
-            <a:pPr algn="l"/>
-            <a:r>
-              <a:rPr sz="1060">
-                <a:latin typeface="Malgun Gothic"/>
-              </a:rPr>
-              <a:t>• 지도에서 수요와 신뢰도를 함께 표시</a:t>
+              <a:t>• 실제 호출/승하차 데이터 확보 시 보정
+• 5분·15분 단위 예측으로 확장
+• 지도에서 수요와 신뢰도를 함께 표시</a:t>
             </a:r>
           </a:p>
         </p:txBody>
@@ -4968,7 +4907,7 @@
                 <a:ea typeface="Arial" pitchFamily="34" charset="-122"/>
                 <a:cs typeface="Arial" pitchFamily="34" charset="-120"/>
               </a:rPr>
-              <a:t>🌐  (배포 URL)</a:t>
+              <a:t>🌐  yeoksam-taxi.kenny31.workers.dev</a:t>
             </a:r>
             <a:endParaRPr lang="en-US" sz="1300" dirty="0"/>
           </a:p>
@@ -5366,7 +5305,7 @@
               <a:rPr sz="1050">
                 <a:latin typeface="Malgun Gothic"/>
               </a:rPr>
-              <a:t>1~4: 문제 정의와 명세서 대비 변경</a:t>
+              <a:t>1~4: 문제 정의와 범위 변경</a:t>
             </a:r>
             <a:endParaRPr lang="en-US" sz="1100" dirty="0"/>
           </a:p>
@@ -5496,7 +5435,7 @@
               <a:rPr sz="1500" b="1">
                 <a:latin typeface="Malgun Gothic"/>
               </a:rPr>
-              <a:t>웹 구현·배포</a:t>
+              <a:t>지도 구현·배포</a:t>
             </a:r>
             <a:endParaRPr lang="en-US" sz="1400" dirty="0"/>
           </a:p>
@@ -5530,7 +5469,7 @@
               <a:rPr sz="1050">
                 <a:latin typeface="Malgun Gothic"/>
               </a:rPr>
-              <a:t>5~8: Three.js·OSM·Cloudflare</a:t>
+              <a:t>5~8: OSM·Three.js·Cloudflare</a:t>
             </a:r>
             <a:endParaRPr lang="en-US" sz="1100" dirty="0"/>
           </a:p>
@@ -5660,7 +5599,7 @@
               <a:rPr sz="1500" b="1">
                 <a:latin typeface="Malgun Gothic"/>
               </a:rPr>
-              <a:t>데이터 수집·학습</a:t>
+              <a:t>데이터 수집·모델</a:t>
             </a:r>
             <a:endParaRPr lang="en-US" sz="1400" dirty="0"/>
           </a:p>
@@ -5694,7 +5633,7 @@
               <a:rPr sz="1050">
                 <a:latin typeface="Malgun Gothic"/>
               </a:rPr>
-              <a:t>9~11: 공개 데이터와 Colab 모델</a:t>
+              <a:t>9~11: proxy 데이터와 Colab 결과</a:t>
             </a:r>
             <a:endParaRPr lang="en-US" sz="1100" dirty="0"/>
           </a:p>
@@ -5824,7 +5763,7 @@
               <a:rPr sz="1500" b="1">
                 <a:latin typeface="Malgun Gothic"/>
               </a:rPr>
-              <a:t>서비스 연결·다음 단계</a:t>
+              <a:t>서비스 연결·한계</a:t>
             </a:r>
             <a:endParaRPr lang="en-US" sz="1400" dirty="0"/>
           </a:p>
@@ -5858,7 +5797,7 @@
               <a:rPr sz="1050">
                 <a:latin typeface="Malgun Gothic"/>
               </a:rPr>
-              <a:t>12~14: 사이트 반영과 개선 계획</a:t>
+              <a:t>12~14: 프로토타입과 다음 단계</a:t>
             </a:r>
             <a:endParaRPr lang="en-US" sz="1100" dirty="0"/>
           </a:p>
@@ -6234,17 +6173,17 @@
               <a:buNone/>
             </a:pPr>
             <a:r>
-              <a:rPr sz="1350">
+              <a:rPr sz="1300">
                 <a:latin typeface="Malgun Gothic"/>
               </a:rPr>
-              <a:t>역삼동 실제 도로망을</a:t>
+              <a:t>강남 9개 동 실제 도로망을</a:t>
             </a:r>
             <a:endParaRPr lang="en-US" sz="1200" dirty="0"/>
           </a:p>
           <a:p>
             <a:pPr algn="ctr"/>
             <a:r>
-              <a:rPr sz="1350">
+              <a:rPr sz="1300">
                 <a:latin typeface="Malgun Gothic"/>
               </a:rPr>
               <a:t>3D로 가상화한 환경에서</a:t>
@@ -6253,10 +6192,10 @@
           <a:p>
             <a:pPr algn="ctr"/>
             <a:r>
-              <a:rPr sz="1350">
+              <a:rPr sz="1300">
                 <a:latin typeface="Malgun Gothic"/>
               </a:rPr>
-              <a:t>이동 수요·배차 시뮬레이션</a:t>
+              <a:t>이동 수요·차량 흐름 시뮬레이션</a:t>
             </a:r>
           </a:p>
         </p:txBody>
@@ -6431,30 +6370,51 @@
               <a:buNone/>
             </a:pPr>
             <a:r>
-              <a:rPr sz="1300">
-                <a:latin typeface="Malgun Gothic"/>
-              </a:rPr>
-              <a:t>대중교통 승차량 기반</a:t>
+              <a:rPr lang="en-US" sz="1200" dirty="0">
+                <a:solidFill>
+                  <a:srgbClr val="5C5C5C"/>
+                </a:solidFill>
+                <a:latin typeface="Arial" pitchFamily="34" charset="0"/>
+                <a:ea typeface="Arial" pitchFamily="34" charset="-122"/>
+                <a:cs typeface="Arial" pitchFamily="34" charset="-120"/>
+              </a:rPr>
+              <a:t>시공간 피처 기반</a:t>
             </a:r>
             <a:endParaRPr lang="en-US" sz="1200" dirty="0"/>
           </a:p>
           <a:p>
-            <a:pPr algn="ctr"/>
-            <a:r>
-              <a:rPr sz="1300">
-                <a:latin typeface="Malgun Gothic"/>
+            <a:pPr marL="0" indent="0" algn="ctr">
+              <a:buNone/>
+            </a:pPr>
+            <a:r>
+              <a:rPr lang="en-US" sz="1200" dirty="0">
+                <a:solidFill>
+                  <a:srgbClr val="5C5C5C"/>
+                </a:solidFill>
+                <a:latin typeface="Arial" pitchFamily="34" charset="0"/>
+                <a:ea typeface="Arial" pitchFamily="34" charset="-122"/>
+                <a:cs typeface="Arial" pitchFamily="34" charset="-120"/>
               </a:rPr>
               <a:t>HistGradientBoosting 모델로</a:t>
             </a:r>
-          </a:p>
-          <a:p>
-            <a:pPr algn="ctr"/>
-            <a:r>
-              <a:rPr sz="1300">
-                <a:latin typeface="Malgun Gothic"/>
+            <a:endParaRPr lang="en-US" sz="1200" dirty="0"/>
+          </a:p>
+          <a:p>
+            <a:pPr marL="0" indent="0" algn="ctr">
+              <a:buNone/>
+            </a:pPr>
+            <a:r>
+              <a:rPr lang="en-US" sz="1200" dirty="0">
+                <a:solidFill>
+                  <a:srgbClr val="5C5C5C"/>
+                </a:solidFill>
+                <a:latin typeface="Arial" pitchFamily="34" charset="0"/>
+                <a:ea typeface="Arial" pitchFamily="34" charset="-122"/>
+                <a:cs typeface="Arial" pitchFamily="34" charset="-120"/>
               </a:rPr>
               <a:t>1시간 뒤 이동 수요 proxy 예측</a:t>
             </a:r>
+            <a:endParaRPr lang="en-US" sz="1200" dirty="0"/>
           </a:p>
         </p:txBody>
       </p:sp>
@@ -7133,15 +7093,10 @@
               <a:buNone/>
             </a:pPr>
             <a:r>
-              <a:rPr lang="en-US" sz="1100" dirty="0">
-                <a:solidFill>
-                  <a:srgbClr val="166534"/>
-                </a:solidFill>
-                <a:latin typeface="Arial" pitchFamily="34" charset="0"/>
-                <a:ea typeface="Arial" pitchFamily="34" charset="-122"/>
-                <a:cs typeface="Arial" pitchFamily="34" charset="-120"/>
-              </a:rPr>
-              <a:t>✓  역삼동 실제 행정구역</a:t>
+              <a:rPr sz="1400" b="1">
+                <a:latin typeface="Malgun Gothic"/>
+              </a:rPr>
+              <a:t>✓  역삼동 포함 강남 9개 행정동</a:t>
             </a:r>
             <a:endParaRPr lang="en-US" sz="1100" dirty="0"/>
           </a:p>
@@ -7175,7 +7130,7 @@
               <a:rPr sz="1050">
                 <a:latin typeface="Malgun Gothic"/>
               </a:rPr>
-              <a:t>상업·업무 밀집 지역 특성을 반영해 더 현실적인 실험 가능</a:t>
+              <a:t>강남권 이동 수요가 집중되는 실제 행정구역 반영, 의미 있는 예측 가능</a:t>
             </a:r>
             <a:endParaRPr lang="en-US" sz="1000" dirty="0"/>
           </a:p>
@@ -7464,15 +7419,10 @@
               <a:buNone/>
             </a:pPr>
             <a:r>
-              <a:rPr lang="en-US" sz="1000" dirty="0">
-                <a:solidFill>
-                  <a:srgbClr val="5C5C5C"/>
-                </a:solidFill>
-                <a:latin typeface="Arial" pitchFamily="34" charset="0"/>
-                <a:ea typeface="Arial" pitchFamily="34" charset="-122"/>
-                <a:cs typeface="Arial" pitchFamily="34" charset="-120"/>
-              </a:rPr>
-              <a:t>OpenStreetMap에서 역삼동 노드/엣지 추출 → 실제 도로 위상 반영</a:t>
+              <a:rPr sz="1050">
+                <a:latin typeface="Malgun Gothic"/>
+              </a:rPr>
+              <a:t>OpenStreetMap에서 강남 9개 동 도로 노드/엣지 추출 → 실제 도로 위상 반영</a:t>
             </a:r>
             <a:endParaRPr lang="en-US" sz="1000" dirty="0"/>
           </a:p>
@@ -8442,15 +8392,10 @@
               <a:buNone/>
             </a:pPr>
             <a:r>
-              <a:rPr lang="en-US" sz="1150" dirty="0">
-                <a:solidFill>
-                  <a:srgbClr val="FFCD00"/>
-                </a:solidFill>
-                <a:latin typeface="Consolas" pitchFamily="34" charset="0"/>
-                <a:ea typeface="Consolas" pitchFamily="34" charset="-122"/>
-                <a:cs typeface="Consolas" pitchFamily="34" charset="-120"/>
-              </a:rPr>
-              <a:t>① Overpass API → 역삼동 bbox 쿼리</a:t>
+              <a:rPr sz="1120">
+                <a:latin typeface="Malgun Gothic"/>
+              </a:rPr>
+              <a:t>① Overpass API → 강남 9개 동 boundary/bbox 쿼리</a:t>
             </a:r>
             <a:endParaRPr lang="en-US" sz="1150" dirty="0"/>
           </a:p>
@@ -8642,7 +8587,7 @@
                 <a:ea typeface="Consolas" pitchFamily="34" charset="-122"/>
                 <a:cs typeface="Consolas" pitchFamily="34" charset="-120"/>
               </a:rPr>
-              <a:t>④ Edge 연결 → 그래프 구조 (NetworkX)</a:t>
+              <a:t>④ Edge 연결 → 도로 그래프 JSON 구성</a:t>
             </a:r>
             <a:endParaRPr lang="en-US" sz="1150" dirty="0"/>
           </a:p>
@@ -8698,15 +8643,10 @@
               <a:buNone/>
             </a:pPr>
             <a:r>
-              <a:rPr lang="en-US" sz="1150" dirty="0">
-                <a:solidFill>
-                  <a:srgbClr val="FFFFFF"/>
-                </a:solidFill>
-                <a:latin typeface="Consolas" pitchFamily="34" charset="0"/>
-                <a:ea typeface="Consolas" pitchFamily="34" charset="-122"/>
-                <a:cs typeface="Consolas" pitchFamily="34" charset="-120"/>
-              </a:rPr>
-              <a:t>⑤ Three.js Line / TubeGeometry 렌더</a:t>
+              <a:rPr sz="1120">
+                <a:latin typeface="Malgun Gothic"/>
+              </a:rPr>
+              <a:t>⑤ Three.js InstancedMesh / LineSegments 렌더</a:t>
             </a:r>
             <a:endParaRPr lang="en-US" sz="1150" dirty="0"/>
           </a:p>
@@ -8946,15 +8886,10 @@
               <a:buNone/>
             </a:pPr>
             <a:r>
-              <a:rPr lang="en-US" sz="1100" dirty="0">
-                <a:solidFill>
-                  <a:srgbClr val="2D2D2D"/>
-                </a:solidFill>
-                <a:latin typeface="Arial" pitchFamily="34" charset="0"/>
-                <a:ea typeface="Arial" pitchFamily="34" charset="-122"/>
-                <a:cs typeface="Arial" pitchFamily="34" charset="-120"/>
-              </a:rPr>
-              <a:t>역삼동 3D 지도 + 조명 설정</a:t>
+              <a:rPr sz="1050">
+                <a:latin typeface="Malgun Gothic"/>
+              </a:rPr>
+              <a:t>강남 9개 동 3D 지도 + 조명 설정</a:t>
             </a:r>
             <a:endParaRPr lang="en-US" sz="1100" dirty="0"/>
           </a:p>
@@ -10639,8 +10574,13 @@
               <a:buNone/>
             </a:pPr>
             <a:r>
-              <a:rPr sz="2600" b="1">
-                <a:latin typeface="Malgun Gothic"/>
+              <a:rPr lang="en-US" sz="2600" b="1" dirty="0">
+                <a:solidFill>
+                  <a:srgbClr val="1A1A1A"/>
+                </a:solidFill>
+                <a:latin typeface="Arial Black" pitchFamily="34" charset="0"/>
+                <a:ea typeface="Arial Black" pitchFamily="34" charset="-122"/>
+                <a:cs typeface="Arial Black" pitchFamily="34" charset="-120"/>
               </a:rPr>
               <a:t>4개 모듈 통합 아키텍처</a:t>
             </a:r>
@@ -10850,32 +10790,10 @@
               <a:buNone/>
             </a:pPr>
             <a:r>
-              <a:rPr lang="en-US" sz="1100" dirty="0">
-                <a:solidFill>
-                  <a:srgbClr val="CCCCCC"/>
-                </a:solidFill>
-                <a:latin typeface="Arial" pitchFamily="34" charset="0"/>
-                <a:ea typeface="Arial" pitchFamily="34" charset="-122"/>
-                <a:cs typeface="Arial" pitchFamily="34" charset="-120"/>
-              </a:rPr>
-              <a:t>Three.js · OSM</a:t>
-            </a:r>
-            <a:endParaRPr lang="en-US" sz="1100" dirty="0"/>
-          </a:p>
-          <a:p>
-            <a:pPr marL="0" indent="0" algn="ctr">
-              <a:buNone/>
-            </a:pPr>
-            <a:r>
-              <a:rPr lang="en-US" sz="1100" dirty="0">
-                <a:solidFill>
-                  <a:srgbClr val="CCCCCC"/>
-                </a:solidFill>
-                <a:latin typeface="Arial" pitchFamily="34" charset="0"/>
-                <a:ea typeface="Arial" pitchFamily="34" charset="-122"/>
-                <a:cs typeface="Arial" pitchFamily="34" charset="-120"/>
-              </a:rPr>
-              <a:t>역삼동 3D 환경</a:t>
+              <a:rPr sz="1080">
+                <a:latin typeface="Malgun Gothic"/>
+              </a:rPr>
+              <a:t>Three.js · OSM | 강남 9개 동 3D 환경</a:t>
             </a:r>
             <a:endParaRPr lang="en-US" sz="1100" dirty="0"/>
           </a:p>
@@ -11041,21 +10959,34 @@
               <a:buNone/>
             </a:pPr>
             <a:r>
-              <a:rPr sz="1700" b="1">
-                <a:latin typeface="Malgun Gothic"/>
-              </a:rPr>
-              <a:t>공개 데이터</a:t>
+              <a:rPr lang="en-US" sz="1400" b="1" dirty="0">
+                <a:solidFill>
+                  <a:srgbClr val="FFFFFF"/>
+                </a:solidFill>
+                <a:latin typeface="Arial" pitchFamily="34" charset="0"/>
+                <a:ea typeface="Arial" pitchFamily="34" charset="-122"/>
+                <a:cs typeface="Arial" pitchFamily="34" charset="-120"/>
+              </a:rPr>
+              <a:t>시공간 데이터</a:t>
             </a:r>
             <a:endParaRPr lang="en-US" sz="1400" dirty="0"/>
           </a:p>
           <a:p>
-            <a:pPr algn="ctr"/>
-            <a:r>
-              <a:rPr sz="1700" b="1">
-                <a:latin typeface="Malgun Gothic"/>
+            <a:pPr marL="0" indent="0" algn="ctr">
+              <a:buNone/>
+            </a:pPr>
+            <a:r>
+              <a:rPr lang="en-US" sz="1400" b="1" dirty="0">
+                <a:solidFill>
+                  <a:srgbClr val="FFFFFF"/>
+                </a:solidFill>
+                <a:latin typeface="Arial" pitchFamily="34" charset="0"/>
+                <a:ea typeface="Arial" pitchFamily="34" charset="-122"/>
+                <a:cs typeface="Arial" pitchFamily="34" charset="-120"/>
               </a:rPr>
               <a:t>전처리</a:t>
             </a:r>
+            <a:endParaRPr lang="en-US" sz="1400" dirty="0"/>
           </a:p>
         </p:txBody>
       </p:sp>
@@ -11109,21 +11040,34 @@
               <a:buNone/>
             </a:pPr>
             <a:r>
-              <a:rPr sz="1150">
-                <a:latin typeface="Malgun Gothic"/>
-              </a:rPr>
-              <a:t>행정동·시간대 정렬</a:t>
+              <a:rPr lang="en-US" sz="1100" dirty="0">
+                <a:solidFill>
+                  <a:srgbClr val="CCCCCC"/>
+                </a:solidFill>
+                <a:latin typeface="Arial" pitchFamily="34" charset="0"/>
+                <a:ea typeface="Arial" pitchFamily="34" charset="-122"/>
+                <a:cs typeface="Arial" pitchFamily="34" charset="-120"/>
+              </a:rPr>
+              <a:t>행정동 단위 OD</a:t>
             </a:r>
             <a:endParaRPr lang="en-US" sz="1100" dirty="0"/>
           </a:p>
           <a:p>
-            <a:pPr algn="ctr"/>
-            <a:r>
-              <a:rPr sz="1150">
-                <a:latin typeface="Malgun Gothic"/>
-              </a:rPr>
-              <a:t>날씨·휴일·Lag Feature 생성</a:t>
-            </a:r>
+            <a:pPr marL="0" indent="0" algn="ctr">
+              <a:buNone/>
+            </a:pPr>
+            <a:r>
+              <a:rPr lang="en-US" sz="1100" dirty="0">
+                <a:solidFill>
+                  <a:srgbClr val="CCCCCC"/>
+                </a:solidFill>
+                <a:latin typeface="Arial" pitchFamily="34" charset="0"/>
+                <a:ea typeface="Arial" pitchFamily="34" charset="-122"/>
+                <a:cs typeface="Arial" pitchFamily="34" charset="-120"/>
+              </a:rPr>
+              <a:t>Lag Feature 생성</a:t>
+            </a:r>
+            <a:endParaRPr lang="en-US" sz="1100" dirty="0"/>
           </a:p>
         </p:txBody>
       </p:sp>
@@ -11368,7 +11312,7 @@
               <a:rPr sz="1150">
                 <a:latin typeface="Malgun Gothic"/>
               </a:rPr>
-              <a:t>MAE 165.7 · R² 0.985</a:t>
+              <a:t>MAE/RMSE/R² 평가</a:t>
             </a:r>
           </a:p>
         </p:txBody>
@@ -11546,7 +11490,7 @@
               <a:rPr sz="1700" b="1">
                 <a:latin typeface="Malgun Gothic"/>
               </a:rPr>
-              <a:t>지도 시각화</a:t>
+              <a:t>다음 단계</a:t>
             </a:r>
           </a:p>
         </p:txBody>
@@ -11604,7 +11548,7 @@
               <a:rPr sz="1130">
                 <a:latin typeface="Malgun Gothic"/>
               </a:rPr>
-              <a:t>동별 수요 랭킹·색상 overlay</a:t>
+              <a:t>지도 overlay</a:t>
             </a:r>
             <a:endParaRPr lang="en-US" sz="1100" dirty="0"/>
           </a:p>
@@ -12012,16 +11956,37 @@
               </a:lnSpc>
             </a:pPr>
             <a:r>
-              <a:rPr sz="1050" b="0">
-                <a:solidFill>
-                  <a:srgbClr val="1F2937"/>
-                </a:solidFill>
+              <a:rPr sz="1019">
                 <a:latin typeface="Malgun Gothic"/>
               </a:rPr>
-              <a:t>• OSM 기반 도로/건물/행정동 시각화
-• 택시와 일반 교통 흐름 애니메이션
-• 날씨·시간·수요 시나리오 전환
-• 발표 자료 페이지와 바로 연결</a:t>
+              <a:t>• OSM 기반 도로/건물/행정동 시각화</a:t>
+            </a:r>
+          </a:p>
+          <a:p>
+            <a:pPr algn="l"/>
+            <a:r>
+              <a:rPr sz="1019">
+                <a:latin typeface="Malgun Gothic"/>
+              </a:rPr>
+              <a:t>• 택시와 일반 교통 흐름 애니메이션</a:t>
+            </a:r>
+          </a:p>
+          <a:p>
+            <a:pPr algn="l"/>
+            <a:r>
+              <a:rPr sz="1019">
+                <a:latin typeface="Malgun Gothic"/>
+              </a:rPr>
+              <a:t>• 날씨·시간·수요 시나리오 전환</a:t>
+            </a:r>
+          </a:p>
+          <a:p>
+            <a:pPr algn="l"/>
+            <a:r>
+              <a:rPr sz="1019">
+                <a:latin typeface="Malgun Gothic"/>
+              </a:rPr>
+              <a:t>• 발표 자료 페이지와 바로 연결</a:t>
             </a:r>
           </a:p>
         </p:txBody>
@@ -12323,7 +12288,7 @@
                 </a:solidFill>
                 <a:latin typeface="Malgun Gothic"/>
               </a:rPr>
-              <a:t>데이터 수집 개선: 생활인구 proxy에서 대중교통 proxy로 확장</a:t>
+              <a:t>데이터 수집 개선: 생활인구 proxy에서 대중교통 proxy로 전환</a:t>
             </a:r>
           </a:p>
         </p:txBody>

</xml_diff>

<commit_message>
Align presentation deck with deployed Cloudflare target
</commit_message>
<xml_diff>
--- a/public/a-eye-presentation/A-Eye_midterm_data_collection_forecast.pptx
+++ b/public/a-eye-presentation/A-Eye_midterm_data_collection_forecast.pptx
@@ -1629,15 +1629,10 @@
               <a:buNone/>
             </a:pPr>
             <a:r>
-              <a:rPr lang="en-US" sz="1100" b="1" dirty="0">
-                <a:solidFill>
-                  <a:srgbClr val="1A1A1A"/>
-                </a:solidFill>
-                <a:latin typeface="Arial" pitchFamily="34" charset="0"/>
-                <a:ea typeface="Arial" pitchFamily="34" charset="-122"/>
-                <a:cs typeface="Arial" pitchFamily="34" charset="-120"/>
-              </a:rPr>
-              <a:t>Three.js  ·  OpenStreetMap  ·  Cloudflare Pages  ·  scikit-learn</a:t>
+              <a:rPr sz="1300">
+                <a:latin typeface="Malgun Gothic"/>
+              </a:rPr>
+              <a:t>Three.js  ·  OpenStreetMap  ·  Cloudflare Workers  ·  scikit-learn</a:t>
             </a:r>
             <a:endParaRPr lang="en-US" sz="1100" dirty="0"/>
           </a:p>
@@ -2043,13 +2038,10 @@
           <a:p>
             <a:pPr algn="ctr"/>
             <a:r>
-              <a:rPr sz="950" b="0">
-                <a:solidFill>
-                  <a:srgbClr val="5C5C5C"/>
-                </a:solidFill>
+              <a:rPr sz="1100">
                 <a:latin typeface="Malgun Gothic"/>
               </a:rPr>
-              <a:t>학습 row</a:t>
+              <a:t>모델 row</a:t>
             </a:r>
           </a:p>
         </p:txBody>
@@ -7969,15 +7961,10 @@
               <a:buNone/>
             </a:pPr>
             <a:r>
-              <a:rPr lang="en-US" sz="1100" dirty="0">
-                <a:solidFill>
-                  <a:srgbClr val="166534"/>
-                </a:solidFill>
-                <a:latin typeface="Arial" pitchFamily="34" charset="0"/>
-                <a:ea typeface="Arial" pitchFamily="34" charset="-122"/>
-                <a:cs typeface="Arial" pitchFamily="34" charset="-120"/>
-              </a:rPr>
-              <a:t>✓  Cloudflare Pages</a:t>
+              <a:rPr sz="1400" b="1">
+                <a:latin typeface="Malgun Gothic"/>
+              </a:rPr>
+              <a:t>✓  Cloudflare Workers</a:t>
             </a:r>
             <a:endParaRPr lang="en-US" sz="1100" dirty="0"/>
           </a:p>
@@ -9593,15 +9580,10 @@
               <a:buNone/>
             </a:pPr>
             <a:r>
-              <a:rPr lang="en-US" sz="2600" b="1" dirty="0">
-                <a:solidFill>
-                  <a:srgbClr val="1A1A1A"/>
-                </a:solidFill>
-                <a:latin typeface="Arial Black" pitchFamily="34" charset="0"/>
-                <a:ea typeface="Arial Black" pitchFamily="34" charset="-122"/>
-                <a:cs typeface="Arial Black" pitchFamily="34" charset="-120"/>
-              </a:rPr>
-              <a:t>Cloudflare Pages 배포</a:t>
+              <a:rPr sz="2800" b="1">
+                <a:latin typeface="Malgun Gothic"/>
+              </a:rPr>
+              <a:t>Cloudflare Workers 배포</a:t>
             </a:r>
             <a:endParaRPr lang="en-US" sz="2600" dirty="0"/>
           </a:p>
@@ -9900,15 +9882,10 @@
               <a:buNone/>
             </a:pPr>
             <a:r>
-              <a:rPr lang="en-US" sz="1200" b="1" dirty="0">
-                <a:solidFill>
-                  <a:srgbClr val="FFFFFF"/>
-                </a:solidFill>
-                <a:latin typeface="Arial" pitchFamily="34" charset="0"/>
-                <a:ea typeface="Arial" pitchFamily="34" charset="-122"/>
-                <a:cs typeface="Arial" pitchFamily="34" charset="-120"/>
-              </a:rPr>
-              <a:t>CF Pages 빌드</a:t>
+              <a:rPr sz="1500" b="1">
+                <a:latin typeface="Malgun Gothic"/>
+              </a:rPr>
+              <a:t>OpenNext 빌드</a:t>
             </a:r>
             <a:endParaRPr lang="en-US" sz="1200" dirty="0"/>
           </a:p>
@@ -10073,15 +10050,10 @@
               <a:buNone/>
             </a:pPr>
             <a:r>
-              <a:rPr lang="en-US" sz="1200" b="1" dirty="0">
-                <a:solidFill>
-                  <a:srgbClr val="FFFFFF"/>
-                </a:solidFill>
-                <a:latin typeface="Arial" pitchFamily="34" charset="0"/>
-                <a:ea typeface="Arial" pitchFamily="34" charset="-122"/>
-                <a:cs typeface="Arial" pitchFamily="34" charset="-120"/>
-              </a:rPr>
-              <a:t>CDN 글로벌 배포</a:t>
+              <a:rPr sz="1500" b="1">
+                <a:latin typeface="Malgun Gothic"/>
+              </a:rPr>
+              <a:t>Cloudflare 배포</a:t>
             </a:r>
             <a:endParaRPr lang="en-US" sz="1200" dirty="0"/>
           </a:p>
@@ -12059,13 +12031,10 @@
           <a:p>
             <a:pPr algn="ctr"/>
             <a:r>
-              <a:rPr sz="850" b="1">
-                <a:solidFill>
-                  <a:srgbClr val="FFFFFF"/>
-                </a:solidFill>
+              <a:rPr sz="1100" b="1">
                 <a:latin typeface="Malgun Gothic"/>
               </a:rPr>
-              <a:t>Three.js · Next.js · Cloudflare Pages</a:t>
+              <a:t>Three.js · Next.js · Cloudflare Workers</a:t>
             </a:r>
           </a:p>
         </p:txBody>

</xml_diff>